<commit_message>
Make dynamic and agentic workflows explicit in a guided demo
Co-authored-by: Copilot App <223556219+Copilot@users.noreply.github.com>
</commit_message>
<xml_diff>
--- a/Launch-Rescue.pptx
+++ b/Launch-Rescue.pptx
@@ -713,7 +713,7 @@
           <a:p>
             <a:r>
               <a:rPr lang="en-US" dirty="0"/>
-              <a:t>8:20–9:20, then remain in the demo. From the project folder use the supplied version-matched SDK launcher after npm ci. It launches only the reviewed project extension and defines both no-tool custom agents explicitly. Keep the SDK terminal open at the checkpoint and type APPROVE there after review. The browser is read-only. For an app-created run, use that app session's Workflows panel. Do not assume CLI and SDK persisted sessions are interoperable.,
+              <a:t>8:20–9:20. Launch the version-matched SDK with --walkthrough. It pauses at feature boundaries using the actual Copilot runtime. Type NEXT at those teaching stops; NEXT is not draft approval. Type APPROVE only at the separate final human checkpoint. The browser shows exact handoffs and never resumes native work. Agent models and effort remain explicit.,
 PRESENTER BOUNDARIES: All launch data is synthetic. Rehearsal uses JavaScript workers, not LLM agents. Native live mode requires eligible Copilot authentication, experimental features, and model availability. No deployment or remote writes.,
 SOURCES (checked 2026-10-10):
 S2: Using dynamic workflows
@@ -2641,7 +2641,7 @@
           <a:p>
             <a:r>
               <a:rPr lang="en-US" dirty="0"/>
-              <a:t>4:30–5:30. Walk the mixed process: capture inputs, deterministic probes in parallel, a specialist when evidence warrants one, deterministic acceptance checks, independent challenge, and a durable pause. The toy fixture makes failures obvious. In real work, put model judgment on unstructured logs, source interpretation, and competing explanations—not arithmetic.,
+              <a:t>4:30–5:30. Point at the two names used throughout the live demo. Dynamic Workflow means code-controlled orchestration: routes, parallel work, journals, and checkpoints. Agentic Workflow means model reasoning inside that process: a cited repair explanation and independent challenge. The model does not invent the workflow program. GitHub Agentic Workflows on Actions is a separate engine and is not run here.,
 PRESENTER BOUNDARIES: All launch data is synthetic. Rehearsal uses JavaScript workers, not LLM agents. Native live mode requires eligible Copilot authentication, experimental features, and model availability. No deployment or remote writes.,
 SOURCES (checked 2026-10-10):
 S1: Dynamic workflows
@@ -2927,7 +2927,7 @@
           <a:p>
             <a:r>
               <a:rPr lang="en-US" dirty="0"/>
-              <a:t>7:00–7:40. Switch to the live demo after this slide. Open Launch-Rescue-Demo.html or the local server. Set Stage view for 1920×1080. Truthfully identify the mode. Native rehearsal is the actual Copilot runtime without models. Native live uses actual model calls. Offline rehearsal is local JavaScript only.,
+              <a:t>7:00–7:40. Switch to the feature walkthrough, not an uninterrupted ticket-allocation animation. At every stop identify the feature name, why it helps, the relevant API, the input, and the output. Native agentic proofs show an exact prompt and actual model response. Offline proofs say JavaScript substitute and label the prompt as a preview not sent to a model.,
 PRESENTER BOUNDARIES: All launch data is synthetic. Rehearsal uses JavaScript workers, not LLM agents. Native live mode requires eligible Copilot authentication, experimental features, and model availability. No deployment or remote writes.,
 SOURCES (checked 2026-10-10):
 S2: Using dynamic workflows
@@ -5103,7 +5103,7 @@
               <a:buNone/>
             </a:pPr>
             <a:r>
-              <a:rPr lang="en-US" sz="2800" dirty="0">
+              <a:rPr lang="en-US" sz="2600" dirty="0">
                 <a:solidFill>
                   <a:srgbClr val="FD8EA1"/>
                 </a:solidFill>
@@ -5111,9 +5111,9 @@
                 <a:ea typeface="Consolas" pitchFamily="34" charset="-122"/>
                 <a:cs typeface="Consolas" pitchFamily="34" charset="-120"/>
               </a:rPr>
-              <a:t>node .\native\Run-Sdk.mjs --live --pause</a:t>
-            </a:r>
-            <a:endParaRPr lang="en-US" sz="2800" dirty="0"/>
+              <a:t>node .\native\Run-Sdk.mjs --live --pause --walkthrough</a:t>
+            </a:r>
+            <a:endParaRPr lang="en-US" sz="2600" dirty="0"/>
           </a:p>
         </p:txBody>
       </p:sp>
@@ -5282,7 +5282,7 @@
         <p:spPr>
           <a:xfrm>
             <a:off x="841248" y="5650992"/>
-            <a:ext cx="10515600" cy="411480"/>
+            <a:ext cx="10515600" cy="502920"/>
           </a:xfrm>
           <a:prstGeom prst="rect">
             <a:avLst/>
@@ -5298,7 +5298,7 @@
               <a:buNone/>
             </a:pPr>
             <a:r>
-              <a:rPr lang="en-US" sz="2300" dirty="0">
+              <a:rPr lang="en-US" sz="2500" b="1" dirty="0">
                 <a:solidFill>
                   <a:srgbClr val="B0B0B0"/>
                 </a:solidFill>
@@ -5306,9 +5306,9 @@
                 <a:ea typeface="Aptos" pitchFamily="34" charset="-122"/>
                 <a:cs typeface="Aptos" pitchFamily="34" charset="-120"/>
               </a:rPr>
-              <a:t>No silent Auto fallback. Live calls consume AI credits.</a:t>
-            </a:r>
-            <a:endParaRPr lang="en-US" sz="2300" dirty="0"/>
+              <a:t>5 teaching stops: NEXT. Final draft review: APPROVE.</a:t>
+            </a:r>
+            <a:endParaRPr lang="en-US" sz="2500" dirty="0"/>
           </a:p>
         </p:txBody>
       </p:sp>
@@ -23937,7 +23937,7 @@
                 <a:ea typeface="Aptos Display" pitchFamily="34" charset="-122"/>
                 <a:cs typeface="Aptos Display" pitchFamily="34" charset="-120"/>
               </a:rPr>
-              <a:t>Code owns the repeatable.</a:t>
+              <a:t>Two features.</a:t>
             </a:r>
             <a:endParaRPr lang="en-US" sz="4200" dirty="0"/>
           </a:p>
@@ -23954,7 +23954,7 @@
                 <a:ea typeface="Aptos Display" pitchFamily="34" charset="-122"/>
                 <a:cs typeface="Aptos Display" pitchFamily="34" charset="-120"/>
               </a:rPr>
-              <a:t>Agents handle judgment.</a:t>
+              <a:t>One controlled process.</a:t>
             </a:r>
             <a:endParaRPr lang="en-US" sz="4200" dirty="0"/>
           </a:p>
@@ -24094,18 +24094,18 @@
         </p:nvSpPr>
         <p:spPr>
           <a:xfrm>
-            <a:off x="640080" y="2359152"/>
-            <a:ext cx="1517904" cy="859536"/>
-          </a:xfrm>
-          <a:prstGeom prst="roundRect">
-            <a:avLst>
-              <a:gd name="adj" fmla="val 10638"/>
+            <a:off x="694944" y="2084832"/>
+            <a:ext cx="5303520" cy="2944368"/>
+          </a:xfrm>
+          <a:prstGeom prst="roundRect">
+            <a:avLst>
+              <a:gd name="adj" fmla="val 3727"/>
             </a:avLst>
           </a:prstGeom>
           <a:solidFill>
             <a:srgbClr val="292929"/>
           </a:solidFill>
-          <a:ln w="16510">
+          <a:ln w="12700">
             <a:solidFill>
               <a:srgbClr val="5F5F5F"/>
             </a:solidFill>
@@ -24121,8 +24121,8 @@
         </p:nvSpPr>
         <p:spPr>
           <a:xfrm>
-            <a:off x="758952" y="2450592"/>
-            <a:ext cx="1280160" cy="676656"/>
+            <a:off x="896112" y="2286000"/>
+            <a:ext cx="4901184" cy="603504"/>
           </a:xfrm>
           <a:prstGeom prst="rect">
             <a:avLst/>
@@ -24134,11 +24134,11 @@
           <a:bodyPr wrap="square" lIns="0" tIns="0" rIns="0" bIns="0" rtlCol="0" anchor="ctr"/>
           <a:lstStyle/>
           <a:p>
-            <a:pPr algn="ctr" indent="0" marL="0">
-              <a:buNone/>
-            </a:pPr>
-            <a:r>
-              <a:rPr lang="en-US" sz="2200" b="1" dirty="0">
+            <a:pPr indent="0" marL="0">
+              <a:buNone/>
+            </a:pPr>
+            <a:r>
+              <a:rPr lang="en-US" sz="3000" b="1" dirty="0">
                 <a:solidFill>
                   <a:srgbClr val="DEDEDE"/>
                 </a:solidFill>
@@ -24146,230 +24146,105 @@
                 <a:ea typeface="Aptos" pitchFamily="34" charset="-122"/>
                 <a:cs typeface="Aptos" pitchFamily="34" charset="-120"/>
               </a:rPr>
-              <a:t>Capture</a:t>
-            </a:r>
-            <a:endParaRPr lang="en-US" sz="2200" dirty="0"/>
-          </a:p>
-        </p:txBody>
-      </p:sp>
-      <p:sp>
-        <p:nvSpPr>
-          <p:cNvPr id="9" name="Shape 6"/>
-          <p:cNvSpPr/>
-          <p:nvPr/>
-        </p:nvSpPr>
-        <p:spPr>
-          <a:xfrm>
-            <a:off x="2468880" y="2359152"/>
-            <a:ext cx="1517904" cy="859536"/>
-          </a:xfrm>
-          <a:prstGeom prst="roundRect">
-            <a:avLst>
-              <a:gd name="adj" fmla="val 10638"/>
-            </a:avLst>
-          </a:prstGeom>
-          <a:solidFill>
-            <a:srgbClr val="292929"/>
-          </a:solidFill>
-          <a:ln w="16510">
-            <a:solidFill>
-              <a:srgbClr val="5F5F5F"/>
-            </a:solidFill>
-            <a:prstDash val="solid"/>
-          </a:ln>
-        </p:spPr>
-      </p:sp>
-      <p:sp>
-        <p:nvSpPr>
-          <p:cNvPr id="10" name="Text 7"/>
-          <p:cNvSpPr/>
-          <p:nvPr/>
-        </p:nvSpPr>
-        <p:spPr>
-          <a:xfrm>
-            <a:off x="2587752" y="2450592"/>
-            <a:ext cx="1280160" cy="676656"/>
-          </a:xfrm>
-          <a:prstGeom prst="rect">
-            <a:avLst/>
-          </a:prstGeom>
-          <a:noFill/>
-          <a:ln/>
-        </p:spPr>
-        <p:txBody>
-          <a:bodyPr wrap="square" lIns="0" tIns="0" rIns="0" bIns="0" rtlCol="0" anchor="ctr"/>
-          <a:lstStyle/>
-          <a:p>
-            <a:pPr algn="ctr" indent="0" marL="0">
-              <a:buNone/>
-            </a:pPr>
-            <a:r>
-              <a:rPr lang="en-US" sz="2200" b="1" dirty="0">
-                <a:solidFill>
-                  <a:srgbClr val="DEDEDE"/>
+              <a:t>Dynamic Workflow</a:t>
+            </a:r>
+            <a:endParaRPr lang="en-US" sz="3000" dirty="0"/>
+          </a:p>
+        </p:txBody>
+      </p:sp>
+      <p:sp>
+        <p:nvSpPr>
+          <p:cNvPr id="9" name="Text 6"/>
+          <p:cNvSpPr/>
+          <p:nvPr/>
+        </p:nvSpPr>
+        <p:spPr>
+          <a:xfrm>
+            <a:off x="896112" y="3017520"/>
+            <a:ext cx="4901184" cy="1847088"/>
+          </a:xfrm>
+          <a:prstGeom prst="rect">
+            <a:avLst/>
+          </a:prstGeom>
+          <a:noFill/>
+          <a:ln/>
+        </p:spPr>
+        <p:txBody>
+          <a:bodyPr wrap="square" lIns="0" tIns="0" rIns="0" bIns="0" rtlCol="0" anchor="t"/>
+          <a:lstStyle/>
+          <a:p>
+            <a:pPr indent="0" marL="0">
+              <a:buNone/>
+            </a:pPr>
+            <a:r>
+              <a:rPr lang="en-US" sz="2600" dirty="0">
+                <a:solidFill>
+                  <a:srgbClr val="B0B0B0"/>
                 </a:solidFill>
                 <a:latin typeface="Aptos" pitchFamily="34" charset="0"/>
                 <a:ea typeface="Aptos" pitchFamily="34" charset="-122"/>
                 <a:cs typeface="Aptos" pitchFamily="34" charset="-120"/>
               </a:rPr>
-              <a:t>Inspect</a:t>
-            </a:r>
-            <a:endParaRPr lang="en-US" sz="2200" dirty="0"/>
-          </a:p>
-        </p:txBody>
-      </p:sp>
-      <p:sp>
-        <p:nvSpPr>
-          <p:cNvPr id="11" name="Shape 8"/>
-          <p:cNvSpPr/>
-          <p:nvPr/>
-        </p:nvSpPr>
-        <p:spPr>
-          <a:xfrm>
-            <a:off x="4297680" y="2359152"/>
-            <a:ext cx="1517904" cy="859536"/>
-          </a:xfrm>
-          <a:prstGeom prst="roundRect">
-            <a:avLst>
-              <a:gd name="adj" fmla="val 10638"/>
-            </a:avLst>
-          </a:prstGeom>
-          <a:solidFill>
-            <a:srgbClr val="FD8EA1"/>
-          </a:solidFill>
-          <a:ln w="16510">
-            <a:solidFill>
-              <a:srgbClr val="FD8EA1"/>
-            </a:solidFill>
-            <a:prstDash val="solid"/>
-          </a:ln>
-        </p:spPr>
-      </p:sp>
-      <p:sp>
-        <p:nvSpPr>
-          <p:cNvPr id="12" name="Text 9"/>
-          <p:cNvSpPr/>
-          <p:nvPr/>
-        </p:nvSpPr>
-        <p:spPr>
-          <a:xfrm>
-            <a:off x="4416552" y="2450592"/>
-            <a:ext cx="1280160" cy="676656"/>
-          </a:xfrm>
-          <a:prstGeom prst="rect">
-            <a:avLst/>
-          </a:prstGeom>
-          <a:noFill/>
-          <a:ln/>
-        </p:spPr>
-        <p:txBody>
-          <a:bodyPr wrap="square" lIns="0" tIns="0" rIns="0" bIns="0" rtlCol="0" anchor="ctr"/>
-          <a:lstStyle/>
-          <a:p>
-            <a:pPr algn="ctr" indent="0" marL="0">
-              <a:buNone/>
-            </a:pPr>
-            <a:r>
-              <a:rPr lang="en-US" sz="1900" b="1" dirty="0">
-                <a:solidFill>
-                  <a:srgbClr val="3D3B3A"/>
+              <a:t>Code picks specialists.</a:t>
+            </a:r>
+            <a:endParaRPr lang="en-US" sz="2600" dirty="0"/>
+          </a:p>
+          <a:p>
+            <a:pPr indent="0" marL="0">
+              <a:buNone/>
+            </a:pPr>
+            <a:r>
+              <a:rPr lang="en-US" sz="2600" dirty="0">
+                <a:solidFill>
+                  <a:srgbClr val="B0B0B0"/>
                 </a:solidFill>
                 <a:latin typeface="Aptos" pitchFamily="34" charset="0"/>
                 <a:ea typeface="Aptos" pitchFamily="34" charset="-122"/>
                 <a:cs typeface="Aptos" pitchFamily="34" charset="-120"/>
               </a:rPr>
-              <a:t>Specialize</a:t>
-            </a:r>
-            <a:endParaRPr lang="en-US" sz="1900" dirty="0"/>
-          </a:p>
-        </p:txBody>
-      </p:sp>
-      <p:sp>
-        <p:nvSpPr>
-          <p:cNvPr id="13" name="Shape 10"/>
-          <p:cNvSpPr/>
-          <p:nvPr/>
-        </p:nvSpPr>
-        <p:spPr>
-          <a:xfrm>
-            <a:off x="6126480" y="2359152"/>
-            <a:ext cx="1517904" cy="859536"/>
-          </a:xfrm>
-          <a:prstGeom prst="roundRect">
-            <a:avLst>
-              <a:gd name="adj" fmla="val 10638"/>
-            </a:avLst>
-          </a:prstGeom>
-          <a:solidFill>
-            <a:srgbClr val="292929"/>
-          </a:solidFill>
-          <a:ln w="16510">
-            <a:solidFill>
-              <a:srgbClr val="5F5F5F"/>
-            </a:solidFill>
-            <a:prstDash val="solid"/>
-          </a:ln>
-        </p:spPr>
-      </p:sp>
-      <p:sp>
-        <p:nvSpPr>
-          <p:cNvPr id="14" name="Text 11"/>
-          <p:cNvSpPr/>
-          <p:nvPr/>
-        </p:nvSpPr>
-        <p:spPr>
-          <a:xfrm>
-            <a:off x="6245352" y="2450592"/>
-            <a:ext cx="1280160" cy="676656"/>
-          </a:xfrm>
-          <a:prstGeom prst="rect">
-            <a:avLst/>
-          </a:prstGeom>
-          <a:noFill/>
-          <a:ln/>
-        </p:spPr>
-        <p:txBody>
-          <a:bodyPr wrap="square" lIns="0" tIns="0" rIns="0" bIns="0" rtlCol="0" anchor="ctr"/>
-          <a:lstStyle/>
-          <a:p>
-            <a:pPr algn="ctr" indent="0" marL="0">
-              <a:buNone/>
-            </a:pPr>
-            <a:r>
-              <a:rPr lang="en-US" sz="2200" b="1" dirty="0">
-                <a:solidFill>
-                  <a:srgbClr val="DEDEDE"/>
+              <a:t>Code branches on failed checks.</a:t>
+            </a:r>
+            <a:endParaRPr lang="en-US" sz="2600" dirty="0"/>
+          </a:p>
+          <a:p>
+            <a:pPr indent="0" marL="0">
+              <a:buNone/>
+            </a:pPr>
+            <a:r>
+              <a:rPr lang="en-US" sz="2600" dirty="0">
+                <a:solidFill>
+                  <a:srgbClr val="B0B0B0"/>
                 </a:solidFill>
                 <a:latin typeface="Aptos" pitchFamily="34" charset="0"/>
                 <a:ea typeface="Aptos" pitchFamily="34" charset="-122"/>
                 <a:cs typeface="Aptos" pitchFamily="34" charset="-120"/>
               </a:rPr>
-              <a:t>Verify</a:t>
-            </a:r>
-            <a:endParaRPr lang="en-US" sz="2200" dirty="0"/>
-          </a:p>
-        </p:txBody>
-      </p:sp>
-      <p:sp>
-        <p:nvSpPr>
-          <p:cNvPr id="15" name="Shape 12"/>
-          <p:cNvSpPr/>
-          <p:nvPr/>
-        </p:nvSpPr>
-        <p:spPr>
-          <a:xfrm>
-            <a:off x="7955280" y="2359152"/>
-            <a:ext cx="1517904" cy="859536"/>
-          </a:xfrm>
-          <a:prstGeom prst="roundRect">
-            <a:avLst>
-              <a:gd name="adj" fmla="val 10638"/>
-            </a:avLst>
-          </a:prstGeom>
-          <a:solidFill>
-            <a:srgbClr val="FD8EA1"/>
-          </a:solidFill>
-          <a:ln w="16510">
+              <a:t>Code saves and pauses.</a:t>
+            </a:r>
+            <a:endParaRPr lang="en-US" sz="2600" dirty="0"/>
+          </a:p>
+        </p:txBody>
+      </p:sp>
+      <p:sp>
+        <p:nvSpPr>
+          <p:cNvPr id="10" name="Shape 7"/>
+          <p:cNvSpPr/>
+          <p:nvPr/>
+        </p:nvSpPr>
+        <p:spPr>
+          <a:xfrm>
+            <a:off x="6217920" y="2084832"/>
+            <a:ext cx="5303520" cy="2944368"/>
+          </a:xfrm>
+          <a:prstGeom prst="roundRect">
+            <a:avLst>
+              <a:gd name="adj" fmla="val 3727"/>
+            </a:avLst>
+          </a:prstGeom>
+          <a:solidFill>
+            <a:srgbClr val="292929"/>
+          </a:solidFill>
+          <a:ln w="25400">
             <a:solidFill>
               <a:srgbClr val="FD8EA1"/>
             </a:solidFill>
@@ -24379,14 +24254,14 @@
       </p:sp>
       <p:sp>
         <p:nvSpPr>
-          <p:cNvPr id="16" name="Text 13"/>
-          <p:cNvSpPr/>
-          <p:nvPr/>
-        </p:nvSpPr>
-        <p:spPr>
-          <a:xfrm>
-            <a:off x="8074152" y="2450592"/>
-            <a:ext cx="1280160" cy="676656"/>
+          <p:cNvPr id="11" name="Text 8"/>
+          <p:cNvSpPr/>
+          <p:nvPr/>
+        </p:nvSpPr>
+        <p:spPr>
+          <a:xfrm>
+            <a:off x="6419088" y="2286000"/>
+            <a:ext cx="4901184" cy="603504"/>
           </a:xfrm>
           <a:prstGeom prst="rect">
             <a:avLst/>
@@ -24398,236 +24273,67 @@
           <a:bodyPr wrap="square" lIns="0" tIns="0" rIns="0" bIns="0" rtlCol="0" anchor="ctr"/>
           <a:lstStyle/>
           <a:p>
-            <a:pPr algn="ctr" indent="0" marL="0">
-              <a:buNone/>
-            </a:pPr>
-            <a:r>
-              <a:rPr lang="en-US" sz="1900" b="1" dirty="0">
-                <a:solidFill>
-                  <a:srgbClr val="3D3B3A"/>
+            <a:pPr indent="0" marL="0">
+              <a:buNone/>
+            </a:pPr>
+            <a:r>
+              <a:rPr lang="en-US" sz="3000" b="1" dirty="0">
+                <a:solidFill>
+                  <a:srgbClr val="DEDEDE"/>
                 </a:solidFill>
                 <a:latin typeface="Aptos" pitchFamily="34" charset="0"/>
                 <a:ea typeface="Aptos" pitchFamily="34" charset="-122"/>
                 <a:cs typeface="Aptos" pitchFamily="34" charset="-120"/>
               </a:rPr>
-              <a:t>Challenge</a:t>
-            </a:r>
-            <a:endParaRPr lang="en-US" sz="1900" dirty="0"/>
-          </a:p>
-        </p:txBody>
-      </p:sp>
-      <p:sp>
-        <p:nvSpPr>
-          <p:cNvPr id="17" name="Shape 14"/>
-          <p:cNvSpPr/>
-          <p:nvPr/>
-        </p:nvSpPr>
-        <p:spPr>
-          <a:xfrm>
-            <a:off x="9784080" y="2359152"/>
-            <a:ext cx="1517904" cy="859536"/>
-          </a:xfrm>
-          <a:prstGeom prst="roundRect">
-            <a:avLst>
-              <a:gd name="adj" fmla="val 10638"/>
-            </a:avLst>
-          </a:prstGeom>
-          <a:solidFill>
-            <a:srgbClr val="292929"/>
-          </a:solidFill>
-          <a:ln w="16510">
-            <a:solidFill>
-              <a:srgbClr val="5F5F5F"/>
-            </a:solidFill>
-            <a:prstDash val="solid"/>
-          </a:ln>
-        </p:spPr>
-      </p:sp>
-      <p:sp>
-        <p:nvSpPr>
-          <p:cNvPr id="18" name="Text 15"/>
-          <p:cNvSpPr/>
-          <p:nvPr/>
-        </p:nvSpPr>
-        <p:spPr>
-          <a:xfrm>
-            <a:off x="9902952" y="2450592"/>
-            <a:ext cx="1280160" cy="676656"/>
-          </a:xfrm>
-          <a:prstGeom prst="rect">
-            <a:avLst/>
-          </a:prstGeom>
-          <a:noFill/>
-          <a:ln/>
-        </p:spPr>
-        <p:txBody>
-          <a:bodyPr wrap="square" lIns="0" tIns="0" rIns="0" bIns="0" rtlCol="0" anchor="ctr"/>
-          <a:lstStyle/>
-          <a:p>
-            <a:pPr algn="ctr" indent="0" marL="0">
-              <a:buNone/>
-            </a:pPr>
-            <a:r>
-              <a:rPr lang="en-US" sz="2200" b="1" dirty="0">
-                <a:solidFill>
-                  <a:srgbClr val="DEDEDE"/>
+              <a:t>Agentic Workflow</a:t>
+            </a:r>
+            <a:endParaRPr lang="en-US" sz="3000" dirty="0"/>
+          </a:p>
+        </p:txBody>
+      </p:sp>
+      <p:sp>
+        <p:nvSpPr>
+          <p:cNvPr id="12" name="Text 9"/>
+          <p:cNvSpPr/>
+          <p:nvPr/>
+        </p:nvSpPr>
+        <p:spPr>
+          <a:xfrm>
+            <a:off x="6419088" y="3017520"/>
+            <a:ext cx="4901184" cy="1847088"/>
+          </a:xfrm>
+          <a:prstGeom prst="rect">
+            <a:avLst/>
+          </a:prstGeom>
+          <a:noFill/>
+          <a:ln/>
+        </p:spPr>
+        <p:txBody>
+          <a:bodyPr wrap="square" lIns="0" tIns="0" rIns="0" bIns="0" rtlCol="0" anchor="t"/>
+          <a:lstStyle/>
+          <a:p>
+            <a:pPr indent="0" marL="0">
+              <a:buNone/>
+            </a:pPr>
+            <a:r>
+              <a:rPr lang="en-US" sz="2600" dirty="0">
+                <a:solidFill>
+                  <a:srgbClr val="B0B0B0"/>
                 </a:solidFill>
                 <a:latin typeface="Aptos" pitchFamily="34" charset="0"/>
                 <a:ea typeface="Aptos" pitchFamily="34" charset="-122"/>
                 <a:cs typeface="Aptos" pitchFamily="34" charset="-120"/>
               </a:rPr>
-              <a:t>Pause</a:t>
-            </a:r>
-            <a:endParaRPr lang="en-US" sz="2200" dirty="0"/>
-          </a:p>
-        </p:txBody>
-      </p:sp>
-      <p:sp>
-        <p:nvSpPr>
-          <p:cNvPr id="19" name="Shape 16"/>
-          <p:cNvSpPr/>
-          <p:nvPr/>
-        </p:nvSpPr>
-        <p:spPr>
-          <a:xfrm>
-            <a:off x="2157984" y="2788920"/>
-            <a:ext cx="310896" cy="0"/>
-          </a:xfrm>
-          <a:prstGeom prst="line">
-            <a:avLst/>
-          </a:prstGeom>
-          <a:noFill/>
-          <a:ln w="25400">
-            <a:solidFill>
-              <a:srgbClr val="FD8EA1"/>
-            </a:solidFill>
-            <a:prstDash val="solid"/>
-            <a:tailEnd type="triangle"/>
-          </a:ln>
-        </p:spPr>
-      </p:sp>
-      <p:sp>
-        <p:nvSpPr>
-          <p:cNvPr id="20" name="Shape 17"/>
-          <p:cNvSpPr/>
-          <p:nvPr/>
-        </p:nvSpPr>
-        <p:spPr>
-          <a:xfrm>
-            <a:off x="3986784" y="2788920"/>
-            <a:ext cx="310896" cy="0"/>
-          </a:xfrm>
-          <a:prstGeom prst="line">
-            <a:avLst/>
-          </a:prstGeom>
-          <a:noFill/>
-          <a:ln w="25400">
-            <a:solidFill>
-              <a:srgbClr val="FD8EA1"/>
-            </a:solidFill>
-            <a:prstDash val="solid"/>
-            <a:tailEnd type="triangle"/>
-          </a:ln>
-        </p:spPr>
-      </p:sp>
-      <p:sp>
-        <p:nvSpPr>
-          <p:cNvPr id="21" name="Shape 18"/>
-          <p:cNvSpPr/>
-          <p:nvPr/>
-        </p:nvSpPr>
-        <p:spPr>
-          <a:xfrm>
-            <a:off x="5815584" y="2788920"/>
-            <a:ext cx="310896" cy="0"/>
-          </a:xfrm>
-          <a:prstGeom prst="line">
-            <a:avLst/>
-          </a:prstGeom>
-          <a:noFill/>
-          <a:ln w="25400">
-            <a:solidFill>
-              <a:srgbClr val="FD8EA1"/>
-            </a:solidFill>
-            <a:prstDash val="solid"/>
-            <a:tailEnd type="triangle"/>
-          </a:ln>
-        </p:spPr>
-      </p:sp>
-      <p:sp>
-        <p:nvSpPr>
-          <p:cNvPr id="22" name="Shape 19"/>
-          <p:cNvSpPr/>
-          <p:nvPr/>
-        </p:nvSpPr>
-        <p:spPr>
-          <a:xfrm>
-            <a:off x="7644384" y="2788920"/>
-            <a:ext cx="310896" cy="0"/>
-          </a:xfrm>
-          <a:prstGeom prst="line">
-            <a:avLst/>
-          </a:prstGeom>
-          <a:noFill/>
-          <a:ln w="25400">
-            <a:solidFill>
-              <a:srgbClr val="FD8EA1"/>
-            </a:solidFill>
-            <a:prstDash val="solid"/>
-            <a:tailEnd type="triangle"/>
-          </a:ln>
-        </p:spPr>
-      </p:sp>
-      <p:sp>
-        <p:nvSpPr>
-          <p:cNvPr id="23" name="Shape 20"/>
-          <p:cNvSpPr/>
-          <p:nvPr/>
-        </p:nvSpPr>
-        <p:spPr>
-          <a:xfrm>
-            <a:off x="9473184" y="2788920"/>
-            <a:ext cx="310896" cy="0"/>
-          </a:xfrm>
-          <a:prstGeom prst="line">
-            <a:avLst/>
-          </a:prstGeom>
-          <a:noFill/>
-          <a:ln w="25400">
-            <a:solidFill>
-              <a:srgbClr val="FD8EA1"/>
-            </a:solidFill>
-            <a:prstDash val="solid"/>
-            <a:tailEnd type="triangle"/>
-          </a:ln>
-        </p:spPr>
-      </p:sp>
-      <p:sp>
-        <p:nvSpPr>
-          <p:cNvPr id="24" name="Text 21"/>
-          <p:cNvSpPr/>
-          <p:nvPr/>
-        </p:nvSpPr>
-        <p:spPr>
-          <a:xfrm>
-            <a:off x="640080" y="3511296"/>
-            <a:ext cx="1517904" cy="393192"/>
-          </a:xfrm>
-          <a:prstGeom prst="rect">
-            <a:avLst/>
-          </a:prstGeom>
-          <a:noFill/>
-          <a:ln/>
-        </p:spPr>
-        <p:txBody>
-          <a:bodyPr wrap="square" lIns="0" tIns="0" rIns="0" bIns="0" rtlCol="0" anchor="ctr"/>
-          <a:lstStyle/>
-          <a:p>
-            <a:pPr algn="ctr" indent="0" marL="0">
-              <a:buNone/>
-            </a:pPr>
-            <a:r>
-              <a:rPr lang="en-US" sz="2000" dirty="0">
+              <a:t>Model interprets evidence.</a:t>
+            </a:r>
+            <a:endParaRPr lang="en-US" sz="2600" dirty="0"/>
+          </a:p>
+          <a:p>
+            <a:pPr indent="0" marL="0">
+              <a:buNone/>
+            </a:pPr>
+            <a:r>
+              <a:rPr lang="en-US" sz="2600" dirty="0">
                 <a:solidFill>
                   <a:srgbClr val="B0B0B0"/>
                 </a:solidFill>
@@ -24635,38 +24341,16 @@
                 <a:ea typeface="Aptos" pitchFamily="34" charset="-122"/>
                 <a:cs typeface="Aptos" pitchFamily="34" charset="-120"/>
               </a:rPr>
-              <a:t>Code</a:t>
-            </a:r>
-            <a:endParaRPr lang="en-US" sz="2000" dirty="0"/>
-          </a:p>
-        </p:txBody>
-      </p:sp>
-      <p:sp>
-        <p:nvSpPr>
-          <p:cNvPr id="25" name="Text 22"/>
-          <p:cNvSpPr/>
-          <p:nvPr/>
-        </p:nvSpPr>
-        <p:spPr>
-          <a:xfrm>
-            <a:off x="2468880" y="3511296"/>
-            <a:ext cx="1517904" cy="393192"/>
-          </a:xfrm>
-          <a:prstGeom prst="rect">
-            <a:avLst/>
-          </a:prstGeom>
-          <a:noFill/>
-          <a:ln/>
-        </p:spPr>
-        <p:txBody>
-          <a:bodyPr wrap="square" lIns="0" tIns="0" rIns="0" bIns="0" rtlCol="0" anchor="ctr"/>
-          <a:lstStyle/>
-          <a:p>
-            <a:pPr algn="ctr" indent="0" marL="0">
-              <a:buNone/>
-            </a:pPr>
-            <a:r>
-              <a:rPr lang="en-US" sz="2000" dirty="0">
+              <a:t>Model explains or rejects.</a:t>
+            </a:r>
+            <a:endParaRPr lang="en-US" sz="2600" dirty="0"/>
+          </a:p>
+          <a:p>
+            <a:pPr indent="0" marL="0">
+              <a:buNone/>
+            </a:pPr>
+            <a:r>
+              <a:rPr lang="en-US" sz="2600" dirty="0">
                 <a:solidFill>
                   <a:srgbClr val="B0B0B0"/>
                 </a:solidFill>
@@ -24674,22 +24358,22 @@
                 <a:ea typeface="Aptos" pitchFamily="34" charset="-122"/>
                 <a:cs typeface="Aptos" pitchFamily="34" charset="-120"/>
               </a:rPr>
-              <a:t>Code</a:t>
-            </a:r>
-            <a:endParaRPr lang="en-US" sz="2000" dirty="0"/>
-          </a:p>
-        </p:txBody>
-      </p:sp>
-      <p:sp>
-        <p:nvSpPr>
-          <p:cNvPr id="26" name="Text 23"/>
-          <p:cNvSpPr/>
-          <p:nvPr/>
-        </p:nvSpPr>
-        <p:spPr>
-          <a:xfrm>
-            <a:off x="4297680" y="3511296"/>
-            <a:ext cx="1517904" cy="393192"/>
+              <a:t>Model never rewrites code.</a:t>
+            </a:r>
+            <a:endParaRPr lang="en-US" sz="2600" dirty="0"/>
+          </a:p>
+        </p:txBody>
+      </p:sp>
+      <p:sp>
+        <p:nvSpPr>
+          <p:cNvPr id="13" name="Text 10"/>
+          <p:cNvSpPr/>
+          <p:nvPr/>
+        </p:nvSpPr>
+        <p:spPr>
+          <a:xfrm>
+            <a:off x="877824" y="5513832"/>
+            <a:ext cx="10469880" cy="603504"/>
           </a:xfrm>
           <a:prstGeom prst="rect">
             <a:avLst/>
@@ -24701,11 +24385,11 @@
           <a:bodyPr wrap="square" lIns="0" tIns="0" rIns="0" bIns="0" rtlCol="0" anchor="ctr"/>
           <a:lstStyle/>
           <a:p>
-            <a:pPr algn="ctr" indent="0" marL="0">
-              <a:buNone/>
-            </a:pPr>
-            <a:r>
-              <a:rPr lang="en-US" sz="2000" dirty="0">
+            <a:pPr indent="0" marL="0">
+              <a:buNone/>
+            </a:pPr>
+            <a:r>
+              <a:rPr lang="en-US" sz="3000" b="1" dirty="0">
                 <a:solidFill>
                   <a:srgbClr val="FD8EA1"/>
                 </a:solidFill>
@@ -24713,180 +24397,7 @@
                 <a:ea typeface="Aptos" pitchFamily="34" charset="-122"/>
                 <a:cs typeface="Aptos" pitchFamily="34" charset="-120"/>
               </a:rPr>
-              <a:t>Judgment</a:t>
-            </a:r>
-            <a:endParaRPr lang="en-US" sz="2000" dirty="0"/>
-          </a:p>
-        </p:txBody>
-      </p:sp>
-      <p:sp>
-        <p:nvSpPr>
-          <p:cNvPr id="27" name="Text 24"/>
-          <p:cNvSpPr/>
-          <p:nvPr/>
-        </p:nvSpPr>
-        <p:spPr>
-          <a:xfrm>
-            <a:off x="6126480" y="3511296"/>
-            <a:ext cx="1517904" cy="393192"/>
-          </a:xfrm>
-          <a:prstGeom prst="rect">
-            <a:avLst/>
-          </a:prstGeom>
-          <a:noFill/>
-          <a:ln/>
-        </p:spPr>
-        <p:txBody>
-          <a:bodyPr wrap="square" lIns="0" tIns="0" rIns="0" bIns="0" rtlCol="0" anchor="ctr"/>
-          <a:lstStyle/>
-          <a:p>
-            <a:pPr algn="ctr" indent="0" marL="0">
-              <a:buNone/>
-            </a:pPr>
-            <a:r>
-              <a:rPr lang="en-US" sz="2000" dirty="0">
-                <a:solidFill>
-                  <a:srgbClr val="B0B0B0"/>
-                </a:solidFill>
-                <a:latin typeface="Aptos" pitchFamily="34" charset="0"/>
-                <a:ea typeface="Aptos" pitchFamily="34" charset="-122"/>
-                <a:cs typeface="Aptos" pitchFamily="34" charset="-120"/>
-              </a:rPr>
-              <a:t>Code</a:t>
-            </a:r>
-            <a:endParaRPr lang="en-US" sz="2000" dirty="0"/>
-          </a:p>
-        </p:txBody>
-      </p:sp>
-      <p:sp>
-        <p:nvSpPr>
-          <p:cNvPr id="28" name="Text 25"/>
-          <p:cNvSpPr/>
-          <p:nvPr/>
-        </p:nvSpPr>
-        <p:spPr>
-          <a:xfrm>
-            <a:off x="7955280" y="3511296"/>
-            <a:ext cx="1517904" cy="393192"/>
-          </a:xfrm>
-          <a:prstGeom prst="rect">
-            <a:avLst/>
-          </a:prstGeom>
-          <a:noFill/>
-          <a:ln/>
-        </p:spPr>
-        <p:txBody>
-          <a:bodyPr wrap="square" lIns="0" tIns="0" rIns="0" bIns="0" rtlCol="0" anchor="ctr"/>
-          <a:lstStyle/>
-          <a:p>
-            <a:pPr algn="ctr" indent="0" marL="0">
-              <a:buNone/>
-            </a:pPr>
-            <a:r>
-              <a:rPr lang="en-US" sz="2000" dirty="0">
-                <a:solidFill>
-                  <a:srgbClr val="FD8EA1"/>
-                </a:solidFill>
-                <a:latin typeface="Aptos" pitchFamily="34" charset="0"/>
-                <a:ea typeface="Aptos" pitchFamily="34" charset="-122"/>
-                <a:cs typeface="Aptos" pitchFamily="34" charset="-120"/>
-              </a:rPr>
-              <a:t>Judgment</a:t>
-            </a:r>
-            <a:endParaRPr lang="en-US" sz="2000" dirty="0"/>
-          </a:p>
-        </p:txBody>
-      </p:sp>
-      <p:sp>
-        <p:nvSpPr>
-          <p:cNvPr id="29" name="Text 26"/>
-          <p:cNvSpPr/>
-          <p:nvPr/>
-        </p:nvSpPr>
-        <p:spPr>
-          <a:xfrm>
-            <a:off x="9784080" y="3511296"/>
-            <a:ext cx="1517904" cy="393192"/>
-          </a:xfrm>
-          <a:prstGeom prst="rect">
-            <a:avLst/>
-          </a:prstGeom>
-          <a:noFill/>
-          <a:ln/>
-        </p:spPr>
-        <p:txBody>
-          <a:bodyPr wrap="square" lIns="0" tIns="0" rIns="0" bIns="0" rtlCol="0" anchor="ctr"/>
-          <a:lstStyle/>
-          <a:p>
-            <a:pPr algn="ctr" indent="0" marL="0">
-              <a:buNone/>
-            </a:pPr>
-            <a:r>
-              <a:rPr lang="en-US" sz="2000" dirty="0">
-                <a:solidFill>
-                  <a:srgbClr val="B0B0B0"/>
-                </a:solidFill>
-                <a:latin typeface="Aptos" pitchFamily="34" charset="0"/>
-                <a:ea typeface="Aptos" pitchFamily="34" charset="-122"/>
-                <a:cs typeface="Aptos" pitchFamily="34" charset="-120"/>
-              </a:rPr>
-              <a:t>Human</a:t>
-            </a:r>
-            <a:endParaRPr lang="en-US" sz="2000" dirty="0"/>
-          </a:p>
-        </p:txBody>
-      </p:sp>
-      <p:sp>
-        <p:nvSpPr>
-          <p:cNvPr id="30" name="Text 27"/>
-          <p:cNvSpPr/>
-          <p:nvPr/>
-        </p:nvSpPr>
-        <p:spPr>
-          <a:xfrm>
-            <a:off x="731520" y="4645152"/>
-            <a:ext cx="10789920" cy="1060704"/>
-          </a:xfrm>
-          <a:prstGeom prst="rect">
-            <a:avLst/>
-          </a:prstGeom>
-          <a:noFill/>
-          <a:ln/>
-        </p:spPr>
-        <p:txBody>
-          <a:bodyPr wrap="square" lIns="0" tIns="0" rIns="0" bIns="0" rtlCol="0" anchor="ctr"/>
-          <a:lstStyle/>
-          <a:p>
-            <a:pPr indent="0" marL="0">
-              <a:buNone/>
-            </a:pPr>
-            <a:r>
-              <a:rPr lang="en-US" sz="3000" b="1" dirty="0">
-                <a:solidFill>
-                  <a:srgbClr val="DEDEDE"/>
-                </a:solidFill>
-                <a:latin typeface="Aptos" pitchFamily="34" charset="0"/>
-                <a:ea typeface="Aptos" pitchFamily="34" charset="-122"/>
-                <a:cs typeface="Aptos" pitchFamily="34" charset="-120"/>
-              </a:rPr>
-              <a:t>Don't spend an agent on a calculation.</a:t>
-            </a:r>
-            <a:endParaRPr lang="en-US" sz="3000" dirty="0"/>
-          </a:p>
-          <a:p>
-            <a:pPr indent="0" marL="0">
-              <a:buNone/>
-            </a:pPr>
-            <a:r>
-              <a:rPr lang="en-US" sz="3000" b="1" dirty="0">
-                <a:solidFill>
-                  <a:srgbClr val="DEDEDE"/>
-                </a:solidFill>
-                <a:latin typeface="Aptos" pitchFamily="34" charset="0"/>
-                <a:ea typeface="Aptos" pitchFamily="34" charset="-122"/>
-                <a:cs typeface="Aptos" pitchFamily="34" charset="-120"/>
-              </a:rPr>
-              <a:t>Spend one where interpretation changes the decision.</a:t>
+              <a:t>Code owns the process. Models handle judgment.</a:t>
             </a:r>
             <a:endParaRPr lang="en-US" sz="3000" dirty="0"/>
           </a:p>
@@ -26350,7 +25861,7 @@
                 <a:ea typeface="Aptos Display" pitchFamily="34" charset="-122"/>
                 <a:cs typeface="Aptos Display" pitchFamily="34" charset="-120"/>
               </a:rPr>
-              <a:t>Let's put the process on stage.</a:t>
+              <a:t>Identify the feature at every stop.</a:t>
             </a:r>
             <a:endParaRPr lang="en-US" sz="4400" dirty="0"/>
           </a:p>
@@ -26482,9 +25993,309 @@
           </a:p>
         </p:txBody>
       </p:sp>
+      <p:sp>
+        <p:nvSpPr>
+          <p:cNvPr id="7" name="Shape 4"/>
+          <p:cNvSpPr/>
+          <p:nvPr/>
+        </p:nvSpPr>
+        <p:spPr>
+          <a:xfrm>
+            <a:off x="777240" y="1828800"/>
+            <a:ext cx="5102352" cy="859536"/>
+          </a:xfrm>
+          <a:prstGeom prst="roundRect">
+            <a:avLst>
+              <a:gd name="adj" fmla="val 10638"/>
+            </a:avLst>
+          </a:prstGeom>
+          <a:solidFill>
+            <a:srgbClr val="292929"/>
+          </a:solidFill>
+          <a:ln w="16510">
+            <a:solidFill>
+              <a:srgbClr val="5F5F5F"/>
+            </a:solidFill>
+            <a:prstDash val="solid"/>
+          </a:ln>
+        </p:spPr>
+      </p:sp>
+      <p:sp>
+        <p:nvSpPr>
+          <p:cNvPr id="8" name="Text 5"/>
+          <p:cNvSpPr/>
+          <p:nvPr/>
+        </p:nvSpPr>
+        <p:spPr>
+          <a:xfrm>
+            <a:off x="896112" y="1920240"/>
+            <a:ext cx="4864608" cy="676656"/>
+          </a:xfrm>
+          <a:prstGeom prst="rect">
+            <a:avLst/>
+          </a:prstGeom>
+          <a:noFill/>
+          <a:ln/>
+        </p:spPr>
+        <p:txBody>
+          <a:bodyPr wrap="square" lIns="0" tIns="0" rIns="0" bIns="0" rtlCol="0" anchor="ctr"/>
+          <a:lstStyle/>
+          <a:p>
+            <a:pPr algn="ctr" indent="0" marL="0">
+              <a:buNone/>
+            </a:pPr>
+            <a:r>
+              <a:rPr lang="en-US" sz="2900" b="1" dirty="0">
+                <a:solidFill>
+                  <a:srgbClr val="DEDEDE"/>
+                </a:solidFill>
+                <a:latin typeface="Aptos" pitchFamily="34" charset="0"/>
+                <a:ea typeface="Aptos" pitchFamily="34" charset="-122"/>
+                <a:cs typeface="Aptos" pitchFamily="34" charset="-120"/>
+              </a:rPr>
+              <a:t>Dynamic Workflow</a:t>
+            </a:r>
+            <a:endParaRPr lang="en-US" sz="2900" dirty="0"/>
+          </a:p>
+        </p:txBody>
+      </p:sp>
+      <p:sp>
+        <p:nvSpPr>
+          <p:cNvPr id="9" name="Text 6"/>
+          <p:cNvSpPr/>
+          <p:nvPr/>
+        </p:nvSpPr>
+        <p:spPr>
+          <a:xfrm>
+            <a:off x="923544" y="2907792"/>
+            <a:ext cx="4864608" cy="1170432"/>
+          </a:xfrm>
+          <a:prstGeom prst="rect">
+            <a:avLst/>
+          </a:prstGeom>
+          <a:noFill/>
+          <a:ln/>
+        </p:spPr>
+        <p:txBody>
+          <a:bodyPr wrap="square" lIns="0" tIns="0" rIns="0" bIns="0" rtlCol="0" anchor="ctr"/>
+          <a:lstStyle/>
+          <a:p>
+            <a:pPr indent="0" marL="0">
+              <a:buNone/>
+            </a:pPr>
+            <a:r>
+              <a:rPr lang="en-US" sz="2400" b="1" dirty="0">
+                <a:solidFill>
+                  <a:srgbClr val="DEDEDE"/>
+                </a:solidFill>
+                <a:latin typeface="Aptos" pitchFamily="34" charset="0"/>
+                <a:ea typeface="Aptos" pitchFamily="34" charset="-122"/>
+                <a:cs typeface="Aptos" pitchFamily="34" charset="-120"/>
+              </a:rPr>
+              <a:t>CODE chooses the steps.</a:t>
+            </a:r>
+            <a:endParaRPr lang="en-US" sz="2400" dirty="0"/>
+          </a:p>
+          <a:p>
+            <a:pPr indent="0" marL="0">
+              <a:buNone/>
+            </a:pPr>
+            <a:r>
+              <a:rPr lang="en-US" sz="2400" b="1" dirty="0">
+                <a:solidFill>
+                  <a:srgbClr val="DEDEDE"/>
+                </a:solidFill>
+                <a:latin typeface="Aptos" pitchFamily="34" charset="0"/>
+                <a:ea typeface="Aptos" pitchFamily="34" charset="-122"/>
+                <a:cs typeface="Aptos" pitchFamily="34" charset="-120"/>
+              </a:rPr>
+              <a:t>Branches when checks fail.</a:t>
+            </a:r>
+            <a:endParaRPr lang="en-US" sz="2400" dirty="0"/>
+          </a:p>
+          <a:p>
+            <a:pPr indent="0" marL="0">
+              <a:buNone/>
+            </a:pPr>
+            <a:r>
+              <a:rPr lang="en-US" sz="2400" b="1" dirty="0">
+                <a:solidFill>
+                  <a:srgbClr val="DEDEDE"/>
+                </a:solidFill>
+                <a:latin typeface="Aptos" pitchFamily="34" charset="0"/>
+                <a:ea typeface="Aptos" pitchFamily="34" charset="-122"/>
+                <a:cs typeface="Aptos" pitchFamily="34" charset="-120"/>
+              </a:rPr>
+              <a:t>Keeps completed work.</a:t>
+            </a:r>
+            <a:endParaRPr lang="en-US" sz="2400" dirty="0"/>
+          </a:p>
+        </p:txBody>
+      </p:sp>
+      <p:sp>
+        <p:nvSpPr>
+          <p:cNvPr id="10" name="Shape 7"/>
+          <p:cNvSpPr/>
+          <p:nvPr/>
+        </p:nvSpPr>
+        <p:spPr>
+          <a:xfrm>
+            <a:off x="777240" y="4343400"/>
+            <a:ext cx="5102352" cy="859536"/>
+          </a:xfrm>
+          <a:prstGeom prst="roundRect">
+            <a:avLst>
+              <a:gd name="adj" fmla="val 10638"/>
+            </a:avLst>
+          </a:prstGeom>
+          <a:solidFill>
+            <a:srgbClr val="FD8EA1"/>
+          </a:solidFill>
+          <a:ln w="16510">
+            <a:solidFill>
+              <a:srgbClr val="FD8EA1"/>
+            </a:solidFill>
+            <a:prstDash val="solid"/>
+          </a:ln>
+        </p:spPr>
+      </p:sp>
+      <p:sp>
+        <p:nvSpPr>
+          <p:cNvPr id="11" name="Text 8"/>
+          <p:cNvSpPr/>
+          <p:nvPr/>
+        </p:nvSpPr>
+        <p:spPr>
+          <a:xfrm>
+            <a:off x="896112" y="4434840"/>
+            <a:ext cx="4864608" cy="676656"/>
+          </a:xfrm>
+          <a:prstGeom prst="rect">
+            <a:avLst/>
+          </a:prstGeom>
+          <a:noFill/>
+          <a:ln/>
+        </p:spPr>
+        <p:txBody>
+          <a:bodyPr wrap="square" lIns="0" tIns="0" rIns="0" bIns="0" rtlCol="0" anchor="ctr"/>
+          <a:lstStyle/>
+          <a:p>
+            <a:pPr algn="ctr" indent="0" marL="0">
+              <a:buNone/>
+            </a:pPr>
+            <a:r>
+              <a:rPr lang="en-US" sz="2900" b="1" dirty="0">
+                <a:solidFill>
+                  <a:srgbClr val="3D3B3A"/>
+                </a:solidFill>
+                <a:latin typeface="Aptos" pitchFamily="34" charset="0"/>
+                <a:ea typeface="Aptos" pitchFamily="34" charset="-122"/>
+                <a:cs typeface="Aptos" pitchFamily="34" charset="-120"/>
+              </a:rPr>
+              <a:t>Agentic Workflow</a:t>
+            </a:r>
+            <a:endParaRPr lang="en-US" sz="2900" dirty="0"/>
+          </a:p>
+        </p:txBody>
+      </p:sp>
+      <p:sp>
+        <p:nvSpPr>
+          <p:cNvPr id="12" name="Text 9"/>
+          <p:cNvSpPr/>
+          <p:nvPr/>
+        </p:nvSpPr>
+        <p:spPr>
+          <a:xfrm>
+            <a:off x="923544" y="5385816"/>
+            <a:ext cx="4864608" cy="777240"/>
+          </a:xfrm>
+          <a:prstGeom prst="rect">
+            <a:avLst/>
+          </a:prstGeom>
+          <a:noFill/>
+          <a:ln/>
+        </p:spPr>
+        <p:txBody>
+          <a:bodyPr wrap="square" lIns="0" tIns="0" rIns="0" bIns="0" rtlCol="0" anchor="ctr"/>
+          <a:lstStyle/>
+          <a:p>
+            <a:pPr indent="0" marL="0">
+              <a:buNone/>
+            </a:pPr>
+            <a:r>
+              <a:rPr lang="en-US" sz="2400" b="1" dirty="0">
+                <a:solidFill>
+                  <a:srgbClr val="DEDEDE"/>
+                </a:solidFill>
+                <a:latin typeface="Aptos" pitchFamily="34" charset="0"/>
+                <a:ea typeface="Aptos" pitchFamily="34" charset="-122"/>
+                <a:cs typeface="Aptos" pitchFamily="34" charset="-120"/>
+              </a:rPr>
+              <a:t>MODEL interprets evidence.</a:t>
+            </a:r>
+            <a:endParaRPr lang="en-US" sz="2400" dirty="0"/>
+          </a:p>
+          <a:p>
+            <a:pPr indent="0" marL="0">
+              <a:buNone/>
+            </a:pPr>
+            <a:r>
+              <a:rPr lang="en-US" sz="2400" b="1" dirty="0">
+                <a:solidFill>
+                  <a:srgbClr val="DEDEDE"/>
+                </a:solidFill>
+                <a:latin typeface="Aptos" pitchFamily="34" charset="0"/>
+                <a:ea typeface="Aptos" pitchFamily="34" charset="-122"/>
+                <a:cs typeface="Aptos" pitchFamily="34" charset="-120"/>
+              </a:rPr>
+              <a:t>Explains or rejects the repair.</a:t>
+            </a:r>
+            <a:endParaRPr lang="en-US" sz="2400" dirty="0"/>
+          </a:p>
+        </p:txBody>
+      </p:sp>
+      <p:sp>
+        <p:nvSpPr>
+          <p:cNvPr id="13" name="Text 10"/>
+          <p:cNvSpPr/>
+          <p:nvPr/>
+        </p:nvSpPr>
+        <p:spPr>
+          <a:xfrm>
+            <a:off x="6419088" y="1728216"/>
+            <a:ext cx="4828032" cy="429768"/>
+          </a:xfrm>
+          <a:prstGeom prst="rect">
+            <a:avLst/>
+          </a:prstGeom>
+          <a:noFill/>
+          <a:ln/>
+        </p:spPr>
+        <p:txBody>
+          <a:bodyPr wrap="square" lIns="0" tIns="0" rIns="0" bIns="0" rtlCol="0" anchor="ctr"/>
+          <a:lstStyle/>
+          <a:p>
+            <a:pPr indent="0" marL="0">
+              <a:buNone/>
+            </a:pPr>
+            <a:r>
+              <a:rPr lang="en-US" sz="2600" b="1" dirty="0">
+                <a:solidFill>
+                  <a:srgbClr val="FD8EA1"/>
+                </a:solidFill>
+                <a:latin typeface="Aptos" pitchFamily="34" charset="0"/>
+                <a:ea typeface="Aptos" pitchFamily="34" charset="-122"/>
+                <a:cs typeface="Aptos" pitchFamily="34" charset="-120"/>
+              </a:rPr>
+              <a:t>Actual model handoff</a:t>
+            </a:r>
+            <a:endParaRPr lang="en-US" sz="2600" dirty="0"/>
+          </a:p>
+        </p:txBody>
+      </p:sp>
       <p:pic>
         <p:nvPicPr>
-          <p:cNvPr id="7" name="Image 0" descr="Actual offline execution trace: retry specialist, failed acceptance check, new inventory evidence, capacity specialist, and passing second check.">    </p:cNvPr>
+          <p:cNvPr id="14" name="Image 0" descr="Cropped actual native model handoff showing gpt-6.1-sol max and its ctx.agent call.">    </p:cNvPr>
           <p:cNvPicPr>
             <a:picLocks noChangeAspect="1"/>
           </p:cNvPicPr>
@@ -26498,8 +26309,8 @@
         </p:blipFill>
         <p:spPr>
           <a:xfrm>
-            <a:off x="704088" y="1636776"/>
-            <a:ext cx="10771632" cy="4425696"/>
+            <a:off x="6419088" y="2414016"/>
+            <a:ext cx="4828032" cy="1384203"/>
           </a:xfrm>
           <a:prstGeom prst="rect">
             <a:avLst/>
@@ -26508,14 +26319,14 @@
       </p:pic>
       <p:sp>
         <p:nvSpPr>
-          <p:cNvPr id="8" name="Text 4"/>
-          <p:cNvSpPr/>
-          <p:nvPr/>
-        </p:nvSpPr>
-        <p:spPr>
-          <a:xfrm>
-            <a:off x="859536" y="6089904"/>
-            <a:ext cx="10469880" cy="292608"/>
+          <p:cNvPr id="15" name="Text 11"/>
+          <p:cNvSpPr/>
+          <p:nvPr/>
+        </p:nvSpPr>
+        <p:spPr>
+          <a:xfrm>
+            <a:off x="6419088" y="4690872"/>
+            <a:ext cx="4828032" cy="694944"/>
           </a:xfrm>
           <a:prstGeom prst="rect">
             <a:avLst/>
@@ -26531,17 +26342,73 @@
               <a:buNone/>
             </a:pPr>
             <a:r>
-              <a:rPr lang="en-US" sz="1700" dirty="0">
-                <a:solidFill>
-                  <a:srgbClr val="B0B0B0"/>
+              <a:rPr lang="en-US" sz="2400" b="1" dirty="0">
+                <a:solidFill>
+                  <a:srgbClr val="DEDEDE"/>
                 </a:solidFill>
                 <a:latin typeface="Aptos" pitchFamily="34" charset="0"/>
                 <a:ea typeface="Aptos" pitchFamily="34" charset="-122"/>
                 <a:cs typeface="Aptos" pitchFamily="34" charset="-120"/>
               </a:rPr>
-              <a:t>Trace detail: evidence → specialists → checks. Offline rehearsal / no LLM.</a:t>
-            </a:r>
-            <a:endParaRPr lang="en-US" sz="1700" dirty="0"/>
+              <a:t>Evidence in: 500 retry requests</a:t>
+            </a:r>
+            <a:endParaRPr lang="en-US" sz="2400" dirty="0"/>
+          </a:p>
+        </p:txBody>
+      </p:sp>
+      <p:sp>
+        <p:nvSpPr>
+          <p:cNvPr id="16" name="Text 12"/>
+          <p:cNvSpPr/>
+          <p:nvPr/>
+        </p:nvSpPr>
+        <p:spPr>
+          <a:xfrm>
+            <a:off x="6419088" y="5486400"/>
+            <a:ext cx="4828032" cy="667512"/>
+          </a:xfrm>
+          <a:prstGeom prst="rect">
+            <a:avLst/>
+          </a:prstGeom>
+          <a:noFill/>
+          <a:ln/>
+        </p:spPr>
+        <p:txBody>
+          <a:bodyPr wrap="square" lIns="0" tIns="0" rIns="0" bIns="0" rtlCol="0" anchor="ctr"/>
+          <a:lstStyle/>
+          <a:p>
+            <a:pPr indent="0" marL="0">
+              <a:buNone/>
+            </a:pPr>
+            <a:r>
+              <a:rPr lang="en-US" sz="2200" dirty="0">
+                <a:solidFill>
+                  <a:srgbClr val="DEDEDE"/>
+                </a:solidFill>
+                <a:latin typeface="Consolas" pitchFamily="34" charset="0"/>
+                <a:ea typeface="Consolas" pitchFamily="34" charset="-122"/>
+                <a:cs typeface="Consolas" pitchFamily="34" charset="-120"/>
+              </a:rPr>
+              <a:t>repair: dedupe</a:t>
+            </a:r>
+            <a:endParaRPr lang="en-US" sz="2200" dirty="0"/>
+          </a:p>
+          <a:p>
+            <a:pPr indent="0" marL="0">
+              <a:buNone/>
+            </a:pPr>
+            <a:r>
+              <a:rPr lang="en-US" sz="2200" dirty="0">
+                <a:solidFill>
+                  <a:srgbClr val="DEDEDE"/>
+                </a:solidFill>
+                <a:latin typeface="Consolas" pitchFamily="34" charset="0"/>
+                <a:ea typeface="Consolas" pitchFamily="34" charset="-122"/>
+                <a:cs typeface="Consolas" pitchFamily="34" charset="-120"/>
+              </a:rPr>
+              <a:t>cites: E-RETRY</a:t>
+            </a:r>
+            <a:endParaRPr lang="en-US" sz="2200" dirty="0"/>
           </a:p>
         </p:txBody>
       </p:sp>

</xml_diff>

<commit_message>
Refresh isolated portable-support stage kit and verified evidence
One coordinated isolated rebuild: portable presentation command, PDF, HTML, screenshots, actual Windows no-model receipts, and real platform CI receipt. Native live fingerprints stay unchanged; authenticated Mac workflows remain explicitly unverified.

Co-authored-by: Copilot App <223556219+Copilot@users.noreply.github.com>
</commit_message>
<xml_diff>
--- a/Launch-Rescue.pptx
+++ b/Launch-Rescue.pptx
@@ -5111,7 +5111,7 @@
                 <a:ea typeface="Consolas" pitchFamily="34" charset="-122"/>
                 <a:cs typeface="Consolas" pitchFamily="34" charset="-120"/>
               </a:rPr>
-              <a:t>node .\native\Run-Sdk.mjs --live --pause --walkthrough</a:t>
+              <a:t>npm run native -- --live --pause --walkthrough</a:t>
             </a:r>
             <a:endParaRPr lang="en-US" sz="2600" dirty="0"/>
           </a:p>
@@ -26310,7 +26310,7 @@
         <p:spPr>
           <a:xfrm>
             <a:off x="6419088" y="2414016"/>
-            <a:ext cx="4828032" cy="1384203"/>
+            <a:ext cx="4828032" cy="1423541"/>
           </a:xfrm>
           <a:prstGeom prst="rect">
             <a:avLst/>

</xml_diff>